<commit_message>
Update PowerPoint for song #263 in FUBC - Українські
</commit_message>
<xml_diff>
--- a/fubc-ua/263-Вірний Спасителю мій (Пісні Спасенних №262).pptx
+++ b/fubc-ua/263-Вірний Спасителю мій (Пісні Спасенних №262).pptx
@@ -1429,7 +1429,7 @@
         </p:nvSpPr>
         <p:spPr>
           <a:xfrm>
-            <a:off x="1837817" y="3547872"/>
+            <a:off x="1936877" y="3547872"/>
             <a:ext cx="0" cy="1386840"/>
           </a:xfrm>
           <a:prstGeom prst="line">
@@ -1452,7 +1452,7 @@
         </p:nvSpPr>
         <p:spPr>
           <a:xfrm>
-            <a:off x="10360279" y="3547872"/>
+            <a:off x="10261219" y="3547872"/>
             <a:ext cx="0" cy="1386840"/>
           </a:xfrm>
           <a:prstGeom prst="line">
@@ -1475,8 +1475,8 @@
         </p:nvSpPr>
         <p:spPr>
           <a:xfrm>
-            <a:off x="10492359" y="4010152"/>
-            <a:ext cx="792480" cy="462280"/>
+            <a:off x="10360279" y="3921252"/>
+            <a:ext cx="1097280" cy="640080"/>
           </a:xfrm>
           <a:prstGeom prst="rect">
             <a:avLst/>
@@ -1492,9 +1492,9 @@
               <a:buNone/>
             </a:pPr>
             <a:r>
-              <a:rPr lang="en-US" sz="2600" b="1" dirty="0">
+              <a:rPr lang="en-US" sz="3600" b="1" dirty="0">
                 <a:solidFill>
-                  <a:srgbClr val="8A8A8A"/>
+                  <a:srgbClr val="BBBBBB"/>
                 </a:solidFill>
                 <a:latin typeface="Arial" pitchFamily="34" charset="0"/>
                 <a:ea typeface="Arial" pitchFamily="34" charset="-122"/>
@@ -1502,7 +1502,7 @@
               </a:rPr>
               <a:t>×2</a:t>
             </a:r>
-            <a:endParaRPr lang="en-US" sz="2600" dirty="0"/>
+            <a:endParaRPr lang="en-US" sz="3600" dirty="0"/>
           </a:p>
         </p:txBody>
       </p:sp>
@@ -1668,7 +1668,7 @@
         </p:nvSpPr>
         <p:spPr>
           <a:xfrm>
-            <a:off x="2441753" y="3151632"/>
+            <a:off x="2540813" y="3151632"/>
             <a:ext cx="0" cy="2179320"/>
           </a:xfrm>
           <a:prstGeom prst="line">
@@ -1691,7 +1691,7 @@
         </p:nvSpPr>
         <p:spPr>
           <a:xfrm>
-            <a:off x="9756343" y="3151632"/>
+            <a:off x="9657283" y="3151632"/>
             <a:ext cx="0" cy="2179320"/>
           </a:xfrm>
           <a:prstGeom prst="line">
@@ -1714,8 +1714,8 @@
         </p:nvSpPr>
         <p:spPr>
           <a:xfrm>
-            <a:off x="9888423" y="4010152"/>
-            <a:ext cx="792480" cy="462280"/>
+            <a:off x="9756343" y="3921252"/>
+            <a:ext cx="1097280" cy="640080"/>
           </a:xfrm>
           <a:prstGeom prst="rect">
             <a:avLst/>
@@ -1731,9 +1731,9 @@
               <a:buNone/>
             </a:pPr>
             <a:r>
-              <a:rPr lang="en-US" sz="2600" b="1" dirty="0">
+              <a:rPr lang="en-US" sz="3600" b="1" dirty="0">
                 <a:solidFill>
-                  <a:srgbClr val="8A8A8A"/>
+                  <a:srgbClr val="BBBBBB"/>
                 </a:solidFill>
                 <a:latin typeface="Arial" pitchFamily="34" charset="0"/>
                 <a:ea typeface="Arial" pitchFamily="34" charset="-122"/>
@@ -1741,7 +1741,7 @@
               </a:rPr>
               <a:t>×2</a:t>
             </a:r>
-            <a:endParaRPr lang="en-US" sz="2600" dirty="0"/>
+            <a:endParaRPr lang="en-US" sz="3600" dirty="0"/>
           </a:p>
         </p:txBody>
       </p:sp>
@@ -1907,7 +1907,7 @@
         </p:nvSpPr>
         <p:spPr>
           <a:xfrm>
-            <a:off x="1999945" y="3151632"/>
+            <a:off x="2099005" y="3151632"/>
             <a:ext cx="0" cy="2179320"/>
           </a:xfrm>
           <a:prstGeom prst="line">
@@ -1930,7 +1930,7 @@
         </p:nvSpPr>
         <p:spPr>
           <a:xfrm>
-            <a:off x="10198151" y="3151632"/>
+            <a:off x="10099091" y="3151632"/>
             <a:ext cx="0" cy="2179320"/>
           </a:xfrm>
           <a:prstGeom prst="line">
@@ -1953,8 +1953,8 @@
         </p:nvSpPr>
         <p:spPr>
           <a:xfrm>
-            <a:off x="10330231" y="4010152"/>
-            <a:ext cx="792480" cy="462280"/>
+            <a:off x="10198151" y="3921252"/>
+            <a:ext cx="1097280" cy="640080"/>
           </a:xfrm>
           <a:prstGeom prst="rect">
             <a:avLst/>
@@ -1970,9 +1970,9 @@
               <a:buNone/>
             </a:pPr>
             <a:r>
-              <a:rPr lang="en-US" sz="2600" b="1" dirty="0">
+              <a:rPr lang="en-US" sz="3600" b="1" dirty="0">
                 <a:solidFill>
-                  <a:srgbClr val="8A8A8A"/>
+                  <a:srgbClr val="BBBBBB"/>
                 </a:solidFill>
                 <a:latin typeface="Arial" pitchFamily="34" charset="0"/>
                 <a:ea typeface="Arial" pitchFamily="34" charset="-122"/>
@@ -1980,7 +1980,7 @@
               </a:rPr>
               <a:t>×2</a:t>
             </a:r>
-            <a:endParaRPr lang="en-US" sz="2600" dirty="0"/>
+            <a:endParaRPr lang="en-US" sz="3600" dirty="0"/>
           </a:p>
         </p:txBody>
       </p:sp>

</xml_diff>